<commit_message>
fix(windows-runner): handle mapped Codex commands
Keep SDK selection limited to real codex invocations on Windows and fall back cleanly for mapped custom commands.

Also strip UTF-8 BOMs before JSON parsing, preserve Windows path backslashes during command splitting, extend backend smoke coverage, and refresh the usage docs plus overview deck.
</commit_message>
<xml_diff>
--- a/docs/ralph-overview.pptx
+++ b/docs/ralph-overview.pptx
@@ -3169,7 +3169,7 @@
                   <a:srgbClr val="FFFFFF"/>
                 </a:solidFill>
               </a:rPr>
-              <a:t>Ralph overview</a:t>
+              <a:t>Ralph oversikt</a:t>
             </a:r>
           </a:p>
         </p:txBody>
@@ -3203,7 +3203,7 @@
                 </a:solidFill>
                 <a:latin typeface="Aptos Display"/>
               </a:rPr>
-              <a:t>What Ralph is</a:t>
+              <a:t>Hva Ralph er</a:t>
             </a:r>
           </a:p>
         </p:txBody>
@@ -3237,7 +3237,7 @@
                 </a:solidFill>
                 <a:latin typeface="Aptos"/>
               </a:rPr>
-              <a:t>A short intro to the Ralph coding loop and what is specific to this repo.</a:t>
+              <a:t>En kort intro til Ralph-løkken og hva som er spesielt med dette repoet.</a:t>
             </a:r>
           </a:p>
         </p:txBody>
@@ -3272,8 +3272,8 @@
                 </a:solidFill>
                 <a:latin typeface="Aptos Display"/>
               </a:rPr>
-              <a:t>File-based agent loop
-for autonomous coding</a:t>
+              <a:t>Filbasert agentløkke
+for autonom koding</a:t>
             </a:r>
           </a:p>
         </p:txBody>
@@ -3312,7 +3312,7 @@
               </a:defRPr>
             </a:pPr>
             <a:r>
-              <a:t>Ralph is a resumable, PRD-driven coding loop rather than a one-off chat prompt.</a:t>
+              <a:t>Ralph er en gjenopptakbar, PRD-drevet kodingsløkke, ikke bare en enkelt chat-prompt.</a:t>
             </a:r>
           </a:p>
           <a:p>
@@ -3328,7 +3328,7 @@
               </a:defRPr>
             </a:pPr>
             <a:r>
-              <a:t>It works one story at a time in a single-agent, multi-iteration flow.</a:t>
+              <a:t>Den jobber med én story om gangen i en enagent-flyt med flere iterasjoner.</a:t>
             </a:r>
           </a:p>
           <a:p>
@@ -3344,7 +3344,7 @@
               </a:defRPr>
             </a:pPr>
             <a:r>
-              <a:t>State, logs, and progress live on disk, which makes longer runs easier to resume and inspect.</a:t>
+              <a:t>Tilstand, logger og fremdrift lagres på disk, noe som gjør lange kjøringer enklere å gjenoppta og inspisere.</a:t>
             </a:r>
           </a:p>
         </p:txBody>
@@ -3524,7 +3524,7 @@
                   <a:srgbClr val="FFFFFF"/>
                 </a:solidFill>
               </a:rPr>
-              <a:t>How Ralph is used</a:t>
+              <a:t>Hvordan Ralph brukes</a:t>
             </a:r>
           </a:p>
         </p:txBody>
@@ -3558,7 +3558,7 @@
                 </a:solidFill>
                 <a:latin typeface="Aptos Display"/>
               </a:rPr>
-              <a:t>Where Ralph fits best</a:t>
+              <a:t>Når Ralph passer best</a:t>
             </a:r>
           </a:p>
         </p:txBody>
@@ -3592,7 +3592,7 @@
                 </a:solidFill>
                 <a:latin typeface="Aptos"/>
               </a:rPr>
-              <a:t>It is most useful when you want durable progress over several steps.</a:t>
+              <a:t>Det er mest nyttig når du vil ha varig fremdrift over flere steg.</a:t>
             </a:r>
           </a:p>
         </p:txBody>
@@ -3671,7 +3671,7 @@
                 </a:solidFill>
                 <a:latin typeface="Aptos Display"/>
               </a:rPr>
-              <a:t>Good use cases</a:t>
+              <a:t>Gode bruksområder</a:t>
             </a:r>
           </a:p>
         </p:txBody>
@@ -3710,7 +3710,7 @@
               </a:defRPr>
             </a:pPr>
             <a:r>
-              <a:t>Multi-step repo changes where work should survive across iterations.</a:t>
+              <a:t>Flerstegs repoendringer der arbeidet bør overleve på tvers av iterasjoner.</a:t>
             </a:r>
           </a:p>
           <a:p>
@@ -3726,7 +3726,7 @@
               </a:defRPr>
             </a:pPr>
             <a:r>
-              <a:t>PRD or plan-driven implementation with visible progress on disk.</a:t>
+              <a:t>PRD- eller planstyrt implementering med synlig fremdrift på disk.</a:t>
             </a:r>
           </a:p>
           <a:p>
@@ -3742,7 +3742,7 @@
               </a:defRPr>
             </a:pPr>
             <a:r>
-              <a:t>Benchmarking, iterative cleanup, and agent loops that benefit from local logs.</a:t>
+              <a:t>Benchmarking, iterativ opprydding og agentlokker som har nytte av lokale logger.</a:t>
             </a:r>
           </a:p>
         </p:txBody>
@@ -3821,7 +3821,7 @@
                 </a:solidFill>
                 <a:latin typeface="Aptos Display"/>
               </a:rPr>
-              <a:t>Less ideal</a:t>
+              <a:t>Mindre egnet</a:t>
             </a:r>
           </a:p>
         </p:txBody>
@@ -3860,7 +3860,7 @@
               </a:defRPr>
             </a:pPr>
             <a:r>
-              <a:t>Tiny one-file edits where direct agent work is faster than creating a PRD.</a:t>
+              <a:t>Små endringer i én fil der direkte agentarbeid er raskere enn å lage en PRD.</a:t>
             </a:r>
           </a:p>
           <a:p>
@@ -3876,7 +3876,7 @@
               </a:defRPr>
             </a:pPr>
             <a:r>
-              <a:t>Situations where no local verification or repo backpressure exists.</a:t>
+              <a:t>Situasjoner uten lokal verifisering eller reelt tilbakepress fra repoet.</a:t>
             </a:r>
           </a:p>
           <a:p>
@@ -3892,7 +3892,7 @@
               </a:defRPr>
             </a:pPr>
             <a:r>
-              <a:t>Tasks that do not benefit from resumability, logs, or bounded iteration loops.</a:t>
+              <a:t>Oppgaver som ikke har nytte av gjenopptakbarhet, logger eller avgrensede iterasjoner.</a:t>
             </a:r>
           </a:p>
         </p:txBody>
@@ -3994,7 +3994,7 @@
                   <a:srgbClr val="FFFFFF"/>
                 </a:solidFill>
               </a:rPr>
-              <a:t>This repo vs vanilla Ralph</a:t>
+              <a:t>Denne repoen vs vanilla Ralph</a:t>
             </a:r>
           </a:p>
         </p:txBody>
@@ -4028,7 +4028,7 @@
                 </a:solidFill>
                 <a:latin typeface="Aptos Display"/>
               </a:rPr>
-              <a:t>How this repo differs</a:t>
+              <a:t>Hvordan denne repoen skiller seg ut</a:t>
             </a:r>
           </a:p>
         </p:txBody>
@@ -4062,7 +4062,7 @@
                 </a:solidFill>
                 <a:latin typeface="Aptos"/>
               </a:rPr>
-              <a:t>This fork is intentionally not stock Ralph.</a:t>
+              <a:t>Denne forken er bevisst ikke standard Ralph.</a:t>
             </a:r>
           </a:p>
         </p:txBody>
@@ -4101,7 +4101,7 @@
               </a:defRPr>
             </a:pPr>
             <a:r>
-              <a:t>Windows-first Codex runner behavior, including SDK-backed supervision and quieter helper handling.</a:t>
+              <a:t>Windows-først Codex-runner, inkludert SDK-basert supervisjon og roligere håndtering av hjelpeprosesser.</a:t>
             </a:r>
           </a:p>
           <a:p>
@@ -4117,7 +4117,7 @@
               </a:defRPr>
             </a:pPr>
             <a:r>
-              <a:t>Fresh per-iteration context plus bounded progress, recipe, and strategy memory to reduce context rot.</a:t>
+              <a:t>Fersk kontekst per iterasjon, pluss avgrenset fremdrifts-, oppskrifts- og strategiminne for å redusere kontekstrot.</a:t>
             </a:r>
           </a:p>
           <a:p>
@@ -4133,7 +4133,7 @@
               </a:defRPr>
             </a:pPr>
             <a:r>
-              <a:t>Deterministic benchmark suites such as smoke, quick, hourly, and deep for repeatable tuning.</a:t>
+              <a:t>Deterministiske benchmark-suiter som smoke, quick, hourly og deep for repeterbar tuning.</a:t>
             </a:r>
           </a:p>
           <a:p>
@@ -4149,7 +4149,7 @@
               </a:defRPr>
             </a:pPr>
             <a:r>
-              <a:t>Long-run resilience features like heartbeat output, hang recovery, and built-in local verification paths.</a:t>
+              <a:t>Robusthet for lange kjøringer, som heartbeat-utskrift, hang recovery og innebygde lokale verifiseringsløp.</a:t>
             </a:r>
           </a:p>
         </p:txBody>
@@ -4228,7 +4228,7 @@
                 </a:solidFill>
                 <a:latin typeface="Aptos Display"/>
               </a:rPr>
-              <a:t>Bottom line</a:t>
+              <a:t>Kort sagt</a:t>
             </a:r>
           </a:p>
         </p:txBody>
@@ -4267,7 +4267,7 @@
               </a:defRPr>
             </a:pPr>
             <a:r>
-              <a:t>Vanilla Ralph is the base loop idea.</a:t>
+              <a:t>Vanilla Ralph er grunnideen for løkken.</a:t>
             </a:r>
           </a:p>
           <a:p>
@@ -4283,7 +4283,7 @@
               </a:defRPr>
             </a:pPr>
             <a:r>
-              <a:t>This repo is tuned for Codex, Windows, benchmarking, and longer unattended runs.</a:t>
+              <a:t>Denne repoen er tunet for Codex, Windows, benchmarking og lengre ubetjente kjøringer.</a:t>
             </a:r>
           </a:p>
         </p:txBody>

</xml_diff>